<commit_message>
Unify on technical report: related work, model plan, 8-min deck, doc consistency fixes
</commit_message>
<xml_diff>
--- a/deliverables/IS507_Midterm_Presentation.pptx
+++ b/deliverables/IS507_Midterm_Presentation.pptx
@@ -546,24 +546,16 @@
           <a:lstStyle xmlns:a="http://schemas.openxmlformats.org/drawingml/2006/main"/>
           <a:p xmlns:a="http://schemas.openxmlformats.org/drawingml/2006/main">
             <a:r>
-              <a:t>Speaking target: 90 seconds</a:t>
-            </a:r>
-          </a:p>
-          <a:p xmlns:a="http://schemas.openxmlformats.org/drawingml/2006/main">
-            <a:r>
-              <a:t/>
-            </a:r>
-          </a:p>
+              <a:t>BACKUP ONLY Speaking target: 90 seconds</a:t>
+            </a:r>
+          </a:p>
+          <a:p xmlns:a="http://schemas.openxmlformats.org/drawingml/2006/main"/>
           <a:p xmlns:a="http://schemas.openxmlformats.org/drawingml/2006/main">
             <a:r>
               <a:t>A probability becomes an alert only after choosing a rule. At a 50 percent threshold we detect 11 cases and raise 24 false alerts. At 30 percent we detect 1,058 cases, but raise 1,398 false alerts. At 20 percent recall reaches about 74 percent with 5,353 false alerts. These development checks do not select a business policy: the acceptable cost and review capacity are unknown. Separately, the highest-scored ten percent contains 679 cases among 1,409 bookings, about 48 percent compared with 26 percent overall. It still finds only 18 percent of all cases. The error audit shows that the few default alerts tend to have longer lead times. Those small groups suggest where to investigate, without explaining guest motives.</a:t>
             </a:r>
           </a:p>
-          <a:p xmlns:a="http://schemas.openxmlformats.org/drawingml/2006/main">
-            <a:r>
-              <a:t/>
-            </a:r>
-          </a:p>
+          <a:p xmlns:a="http://schemas.openxmlformats.org/drawingml/2006/main"/>
           <a:p xmlns:a="http://schemas.openxmlformats.org/drawingml/2006/main">
             <a:r>
               <a:t>Evidence / sources: tables/threshold_diagnostics.csv; tables/ranking_capacity.csv; tables/error_summary.csv</a:t>
@@ -636,24 +628,16 @@
           <a:lstStyle xmlns:a="http://schemas.openxmlformats.org/drawingml/2006/main"/>
           <a:p xmlns:a="http://schemas.openxmlformats.org/drawingml/2006/main">
             <a:r>
-              <a:t>Speaking target: 45 seconds</a:t>
-            </a:r>
-          </a:p>
-          <a:p xmlns:a="http://schemas.openxmlformats.org/drawingml/2006/main">
-            <a:r>
-              <a:t/>
-            </a:r>
-          </a:p>
-          <a:p xmlns:a="http://schemas.openxmlformats.org/drawingml/2006/main">
-            <a:r>
-              <a:t>Our initial analysis finds limited retrospective ranking and probability improvement. The default alert rule performs poorly, and lower thresholds require explicit choices about false alerts. Original booking-time inputs and a more representative cohort remain unresolved. Our next steps are to examine cohort and error patterns on development data, collect original timestamped inputs and define review capacity before evaluating a practical rule on new bookings. Both members participate in every stage. Zhe places greater emphasis on coding and Zhengxuan on slides, while both understand and explain the full analysis. We are not proposing deployment based on these results.</a:t>
-            </a:r>
-          </a:p>
-          <a:p xmlns:a="http://schemas.openxmlformats.org/drawingml/2006/main">
-            <a:r>
-              <a:t/>
-            </a:r>
-          </a:p>
+              <a:t>Speaking target: 50 seconds</a:t>
+            </a:r>
+          </a:p>
+          <a:p xmlns:a="http://schemas.openxmlformats.org/drawingml/2006/main"/>
+          <a:p xmlns:a="http://schemas.openxmlformats.org/drawingml/2006/main">
+            <a:r>
+              <a:t>Our initial analysis finds limited retrospective ranking and probability improvement. The default alert rule performs poorly, and lower thresholds require explicit choices about false alerts. Original booking-time inputs and a more representative cohort remain unresolved. Our next steps are to examine cohort and error patterns on development data, collect original timestamped inputs and define review capacity before evaluating a practical rule on new bookings. Both members participate in every stage. Zhe places greater emphasis on coding and Zhengxuan on slides, while both understand and explain the full analysis. We are not proposing deployment based on these results. Models under consideration include a random forest comparison with the same restricted features, judged by held-out log loss.</a:t>
+            </a:r>
+          </a:p>
+          <a:p xmlns:a="http://schemas.openxmlformats.org/drawingml/2006/main"/>
           <a:p xmlns:a="http://schemas.openxmlformats.org/drawingml/2006/main">
             <a:r>
               <a:t>Evidence / sources: Project analysis: frozen specification; source-linked results in repository</a:t>
@@ -1086,24 +1070,16 @@
           <a:lstStyle xmlns:a="http://schemas.openxmlformats.org/drawingml/2006/main"/>
           <a:p xmlns:a="http://schemas.openxmlformats.org/drawingml/2006/main">
             <a:r>
-              <a:t>Speaking target: 40 seconds</a:t>
-            </a:r>
-          </a:p>
-          <a:p xmlns:a="http://schemas.openxmlformats.org/drawingml/2006/main">
-            <a:r>
-              <a:t/>
-            </a:r>
-          </a:p>
-          <a:p xmlns:a="http://schemas.openxmlformats.org/drawingml/2006/main">
-            <a:r>
-              <a:t>A booking reserves a room for a future stay. A cancellation calls off the reservation. A no-show means the guest does not arrive. We call both outcomes noncompletion. For example, a Friday reservation that cancels leaves the hotel less certain about occupancy. We chose this applied prediction question to connect customer behavior with service planning. A score might help prioritize booking reviews. Our study measures prediction quality, without measuring money saved or cancellations prevented.</a:t>
-            </a:r>
-          </a:p>
-          <a:p xmlns:a="http://schemas.openxmlformats.org/drawingml/2006/main">
-            <a:r>
-              <a:t/>
-            </a:r>
-          </a:p>
+              <a:t>Speaking target: 50 seconds</a:t>
+            </a:r>
+          </a:p>
+          <a:p xmlns:a="http://schemas.openxmlformats.org/drawingml/2006/main"/>
+          <a:p xmlns:a="http://schemas.openxmlformats.org/drawingml/2006/main">
+            <a:r>
+              <a:t>A booking reserves a room for a future stay. A cancellation calls off the reservation. A no-show means the guest does not arrive. We call both outcomes noncompletion. For example, a Friday reservation that cancels leaves the hotel less certain about occupancy. We chose this applied prediction question to connect customer behavior with service planning. A score might help prioritize booking reviews. Related work supports feasibility: Antonio and colleagues showed cancellation prediction works on resort hotel data, though with a different scope; it is not our benchmark. Our study measures prediction quality, without measuring money saved or cancellations prevented.</a:t>
+            </a:r>
+          </a:p>
+          <a:p xmlns:a="http://schemas.openxmlformats.org/drawingml/2006/main"/>
           <a:p xmlns:a="http://schemas.openxmlformats.org/drawingml/2006/main">
             <a:r>
               <a:t>Evidence / sources: Project analysis: frozen specification; source-linked results in repository</a:t>
@@ -1446,24 +1422,16 @@
           <a:lstStyle xmlns:a="http://schemas.openxmlformats.org/drawingml/2006/main"/>
           <a:p xmlns:a="http://schemas.openxmlformats.org/drawingml/2006/main">
             <a:r>
-              <a:t>Speaking target: 65 seconds</a:t>
-            </a:r>
-          </a:p>
-          <a:p xmlns:a="http://schemas.openxmlformats.org/drawingml/2006/main">
-            <a:r>
-              <a:t/>
-            </a:r>
-          </a:p>
-          <a:p xmlns:a="http://schemas.openxmlformats.org/drawingml/2006/main">
-            <a:r>
-              <a:t>We derive an estimated booking date by subtracting lead time from arrival. Training uses July 2015 through June 2016. Validation uses July through December 2016. Both final status and planned departure must precede each cutoff. A December cancellation for a February stay has a known outcome but fails our departure rule. The rule limits preferential admission of early cancellations for future stays, while defining a selected population. It excludes about 47 percent of validation candidates. A status-only rule would add 4,080 positives, raising the positive fraction from 26.19 to 42.76 percent. Neither rule guarantees an unbiased sample. The existing later test has already been scored; details are in the backup.</a:t>
-            </a:r>
-          </a:p>
-          <a:p xmlns:a="http://schemas.openxmlformats.org/drawingml/2006/main">
-            <a:r>
-              <a:t/>
-            </a:r>
-          </a:p>
+              <a:t>Speaking target: 55 seconds</a:t>
+            </a:r>
+          </a:p>
+          <a:p xmlns:a="http://schemas.openxmlformats.org/drawingml/2006/main"/>
+          <a:p xmlns:a="http://schemas.openxmlformats.org/drawingml/2006/main">
+            <a:r>
+              <a:t>We derive an estimated booking date by subtracting lead time from arrival. Training uses July 2015 through June 2016. Validation uses July through December 2016. Both final status and planned departure must precede each cutoff. A December cancellation for a February stay has a known outcome but fails our departure rule. The rule limits preferential admission of early cancellations for future stays, while defining a selected population. It excludes about 47 percent of validation candidates. Neither rule guarantees an unbiased sample. The existing later test has already been scored; details are in the backup.</a:t>
+            </a:r>
+          </a:p>
+          <a:p xmlns:a="http://schemas.openxmlformats.org/drawingml/2006/main"/>
           <a:p xmlns:a="http://schemas.openxmlformats.org/drawingml/2006/main">
             <a:r>
               <a:t>Evidence / sources: src/utils.py assign_partition; tables/maturity_rule_audit.csv; docs/FINAL_EVALUATION_PROTOCOL.md</a:t>
@@ -4460,26 +4428,8 @@
             </a:defPPr>
           </a:lstStyle>
           <a:p xmlns:a="http://schemas.openxmlformats.org/drawingml/2006/main">
-            <a:pPr>
-              <a:defRPr sz="1275" b="0">
-                <a:solidFill>
-                  <a:srgbClr val="BDD0CF"/>
-                </a:solidFill>
-                <a:latin typeface="Arial"/>
-                <a:ea typeface="Arial"/>
-                <a:cs typeface="Arial"/>
-              </a:defRPr>
-            </a:pPr>
-            <a:r>
-              <a:rPr sz="1275" b="0">
-                <a:solidFill>
-                  <a:srgbClr val="BDD0CF"/>
-                </a:solidFill>
-                <a:latin typeface="Arial"/>
-                <a:ea typeface="Arial"/>
-                <a:cs typeface="Arial"/>
-              </a:rPr>
-              <a:t>IS 507 Midterm  ·  1/11</a:t>
+            <a:r>
+              <a:t>IS 507 Midterm  ·  1/10</a:t>
             </a:r>
           </a:p>
         </p:txBody>
@@ -4790,7 +4740,7 @@
 </file>
 
 <file path=ppt/slides/slide10.xml><?xml version="1.0" encoding="utf-8"?>
-<p:sld xmlns:p="http://schemas.openxmlformats.org/presentationml/2006/main">
+<p:sld xmlns:p="http://schemas.openxmlformats.org/presentationml/2006/main" show="0">
   <p:cSld>
     <p:bg>
       <p:bgPr>
@@ -4852,26 +4802,8 @@
             </a:defPPr>
           </a:lstStyle>
           <a:p xmlns:a="http://schemas.openxmlformats.org/drawingml/2006/main">
-            <a:pPr>
-              <a:defRPr sz="3300" b="1">
-                <a:solidFill>
-                  <a:srgbClr val="16333B"/>
-                </a:solidFill>
-                <a:latin typeface="Arial"/>
-                <a:ea typeface="Arial"/>
-                <a:cs typeface="Arial"/>
-              </a:defRPr>
-            </a:pPr>
-            <a:r>
-              <a:rPr sz="3300" b="1">
-                <a:solidFill>
-                  <a:srgbClr val="16333B"/>
-                </a:solidFill>
-                <a:latin typeface="Arial"/>
-                <a:ea typeface="Arial"/>
-                <a:cs typeface="Arial"/>
-              </a:rPr>
-              <a:t>Alert thresholds: more detections mean more false alerts</a:t>
+            <a:r>
+              <a:t>Backup: alert thresholds and ranking capacity</a:t>
             </a:r>
           </a:p>
         </p:txBody>
@@ -4919,29 +4851,7 @@
               </a:defRPr>
             </a:defPPr>
           </a:lstStyle>
-          <a:p xmlns:a="http://schemas.openxmlformats.org/drawingml/2006/main">
-            <a:pPr>
-              <a:defRPr sz="1275" b="0">
-                <a:solidFill>
-                  <a:srgbClr val="596F75"/>
-                </a:solidFill>
-                <a:latin typeface="Arial"/>
-                <a:ea typeface="Arial"/>
-                <a:cs typeface="Arial"/>
-              </a:defRPr>
-            </a:pPr>
-            <a:r>
-              <a:rPr sz="1275" b="0">
-                <a:solidFill>
-                  <a:srgbClr val="596F75"/>
-                </a:solidFill>
-                <a:latin typeface="Arial"/>
-                <a:ea typeface="Arial"/>
-                <a:cs typeface="Arial"/>
-              </a:rPr>
-              <a:t>IS 507 Midterm  ·  10/11</a:t>
-            </a:r>
-          </a:p>
+          <a:p xmlns:a="http://schemas.openxmlformats.org/drawingml/2006/main"/>
         </p:txBody>
       </p:sp>
       <p:graphicFrame>
@@ -5675,26 +5585,8 @@
             </a:defPPr>
           </a:lstStyle>
           <a:p xmlns:a="http://schemas.openxmlformats.org/drawingml/2006/main">
-            <a:pPr>
-              <a:defRPr sz="1275" b="0">
-                <a:solidFill>
-                  <a:srgbClr val="BDD0CF"/>
-                </a:solidFill>
-                <a:latin typeface="Arial"/>
-                <a:ea typeface="Arial"/>
-                <a:cs typeface="Arial"/>
-              </a:defRPr>
-            </a:pPr>
-            <a:r>
-              <a:rPr sz="1275" b="0">
-                <a:solidFill>
-                  <a:srgbClr val="BDD0CF"/>
-                </a:solidFill>
-                <a:latin typeface="Arial"/>
-                <a:ea typeface="Arial"/>
-                <a:cs typeface="Arial"/>
-              </a:rPr>
-              <a:t>IS 507 Midterm  ·  11/11</a:t>
+            <a:r>
+              <a:t>IS 507 Midterm  ·  10/10</a:t>
             </a:r>
           </a:p>
         </p:txBody>
@@ -8489,26 +8381,8 @@
             </a:defPPr>
           </a:lstStyle>
           <a:p xmlns:a="http://schemas.openxmlformats.org/drawingml/2006/main">
-            <a:pPr>
-              <a:defRPr sz="1275" b="0">
-                <a:solidFill>
-                  <a:srgbClr val="596F75"/>
-                </a:solidFill>
-                <a:latin typeface="Arial"/>
-                <a:ea typeface="Arial"/>
-                <a:cs typeface="Arial"/>
-              </a:defRPr>
-            </a:pPr>
-            <a:r>
-              <a:rPr sz="1275" b="0">
-                <a:solidFill>
-                  <a:srgbClr val="596F75"/>
-                </a:solidFill>
-                <a:latin typeface="Arial"/>
-                <a:ea typeface="Arial"/>
-                <a:cs typeface="Arial"/>
-              </a:rPr>
-              <a:t>IS 507 Midterm  ·  2/11</a:t>
+            <a:r>
+              <a:t>IS 507 Midterm  ·  2/10</a:t>
             </a:r>
           </a:p>
         </p:txBody>
@@ -8893,6 +8767,41 @@
           </a:p>
         </p:txBody>
       </p:sp>
+      <p:sp xmlns:a="http://schemas.openxmlformats.org/drawingml/2006/main">
+        <p:nvSpPr>
+          <p:cNvPr id="7" name="TextBox 6"/>
+          <p:cNvSpPr txBox="1"/>
+          <p:nvPr/>
+        </p:nvSpPr>
+        <p:spPr>
+          <a:xfrm>
+            <a:off x="630936" y="4498848"/>
+            <a:ext cx="10936224" cy="320040"/>
+          </a:xfrm>
+          <a:prstGeom prst="rect">
+            <a:avLst/>
+          </a:prstGeom>
+          <a:noFill/>
+        </p:spPr>
+        <p:txBody>
+          <a:bodyPr wrap="square">
+            <a:spAutoFit/>
+          </a:bodyPr>
+          <a:lstStyle/>
+          <a:p>
+            <a:pPr>
+              <a:defRPr sz="1200" i="1">
+                <a:solidFill>
+                  <a:srgbClr val="555555"/>
+                </a:solidFill>
+              </a:defRPr>
+            </a:pPr>
+            <a:r>
+              <a:t>Related work: Antonio et al. (2017) showed hotel cancellation prediction is feasible on resort-hotel data; different scope, not our benchmark.</a:t>
+            </a:r>
+          </a:p>
+        </p:txBody>
+      </p:sp>
     </p:spTree>
     <p:extLst>
       <p:ext uri="{BB962C8B-B14F-4D97-AF65-F5344CB8AC3E}">
@@ -9034,26 +8943,8 @@
             </a:defPPr>
           </a:lstStyle>
           <a:p xmlns:a="http://schemas.openxmlformats.org/drawingml/2006/main">
-            <a:pPr>
-              <a:defRPr sz="1275" b="0">
-                <a:solidFill>
-                  <a:srgbClr val="596F75"/>
-                </a:solidFill>
-                <a:latin typeface="Arial"/>
-                <a:ea typeface="Arial"/>
-                <a:cs typeface="Arial"/>
-              </a:defRPr>
-            </a:pPr>
-            <a:r>
-              <a:rPr sz="1275" b="0">
-                <a:solidFill>
-                  <a:srgbClr val="596F75"/>
-                </a:solidFill>
-                <a:latin typeface="Arial"/>
-                <a:ea typeface="Arial"/>
-                <a:cs typeface="Arial"/>
-              </a:rPr>
-              <a:t>IS 507 Midterm  ·  3/11</a:t>
+            <a:r>
+              <a:t>IS 507 Midterm  ·  3/10</a:t>
             </a:r>
           </a:p>
         </p:txBody>
@@ -9561,26 +9452,8 @@
             </a:defPPr>
           </a:lstStyle>
           <a:p xmlns:a="http://schemas.openxmlformats.org/drawingml/2006/main">
-            <a:pPr>
-              <a:defRPr sz="1275" b="0">
-                <a:solidFill>
-                  <a:srgbClr val="596F75"/>
-                </a:solidFill>
-                <a:latin typeface="Arial"/>
-                <a:ea typeface="Arial"/>
-                <a:cs typeface="Arial"/>
-              </a:defRPr>
-            </a:pPr>
-            <a:r>
-              <a:rPr sz="1275" b="0">
-                <a:solidFill>
-                  <a:srgbClr val="596F75"/>
-                </a:solidFill>
-                <a:latin typeface="Arial"/>
-                <a:ea typeface="Arial"/>
-                <a:cs typeface="Arial"/>
-              </a:rPr>
-              <a:t>IS 507 Midterm  ·  4/11</a:t>
+            <a:r>
+              <a:t>IS 507 Midterm  ·  4/10</a:t>
             </a:r>
           </a:p>
         </p:txBody>
@@ -10105,26 +9978,8 @@
             </a:defPPr>
           </a:lstStyle>
           <a:p xmlns:a="http://schemas.openxmlformats.org/drawingml/2006/main">
-            <a:pPr>
-              <a:defRPr sz="1275" b="0">
-                <a:solidFill>
-                  <a:srgbClr val="596F75"/>
-                </a:solidFill>
-                <a:latin typeface="Arial"/>
-                <a:ea typeface="Arial"/>
-                <a:cs typeface="Arial"/>
-              </a:defRPr>
-            </a:pPr>
-            <a:r>
-              <a:rPr sz="1275" b="0">
-                <a:solidFill>
-                  <a:srgbClr val="596F75"/>
-                </a:solidFill>
-                <a:latin typeface="Arial"/>
-                <a:ea typeface="Arial"/>
-                <a:cs typeface="Arial"/>
-              </a:rPr>
-              <a:t>IS 507 Midterm  ·  5/11</a:t>
+            <a:r>
+              <a:t>IS 507 Midterm  ·  5/10</a:t>
             </a:r>
           </a:p>
         </p:txBody>
@@ -10650,26 +10505,8 @@
             </a:defPPr>
           </a:lstStyle>
           <a:p xmlns:a="http://schemas.openxmlformats.org/drawingml/2006/main">
-            <a:pPr>
-              <a:defRPr sz="1275" b="0">
-                <a:solidFill>
-                  <a:srgbClr val="596F75"/>
-                </a:solidFill>
-                <a:latin typeface="Arial"/>
-                <a:ea typeface="Arial"/>
-                <a:cs typeface="Arial"/>
-              </a:defRPr>
-            </a:pPr>
-            <a:r>
-              <a:rPr sz="1275" b="0">
-                <a:solidFill>
-                  <a:srgbClr val="596F75"/>
-                </a:solidFill>
-                <a:latin typeface="Arial"/>
-                <a:ea typeface="Arial"/>
-                <a:cs typeface="Arial"/>
-              </a:rPr>
-              <a:t>IS 507 Midterm  ·  6/11</a:t>
+            <a:r>
+              <a:t>IS 507 Midterm  ·  6/10</a:t>
             </a:r>
           </a:p>
         </p:txBody>
@@ -11311,26 +11148,8 @@
             </a:defPPr>
           </a:lstStyle>
           <a:p xmlns:a="http://schemas.openxmlformats.org/drawingml/2006/main">
-            <a:pPr>
-              <a:defRPr sz="1275" b="0">
-                <a:solidFill>
-                  <a:srgbClr val="596F75"/>
-                </a:solidFill>
-                <a:latin typeface="Arial"/>
-                <a:ea typeface="Arial"/>
-                <a:cs typeface="Arial"/>
-              </a:defRPr>
-            </a:pPr>
-            <a:r>
-              <a:rPr sz="1275" b="0">
-                <a:solidFill>
-                  <a:srgbClr val="596F75"/>
-                </a:solidFill>
-                <a:latin typeface="Arial"/>
-                <a:ea typeface="Arial"/>
-                <a:cs typeface="Arial"/>
-              </a:rPr>
-              <a:t>IS 507 Midterm  ·  7/11</a:t>
+            <a:r>
+              <a:t>IS 507 Midterm  ·  7/10</a:t>
             </a:r>
           </a:p>
         </p:txBody>
@@ -11884,26 +11703,8 @@
             </a:defPPr>
           </a:lstStyle>
           <a:p xmlns:a="http://schemas.openxmlformats.org/drawingml/2006/main">
-            <a:pPr>
-              <a:defRPr sz="1275" b="0">
-                <a:solidFill>
-                  <a:srgbClr val="596F75"/>
-                </a:solidFill>
-                <a:latin typeface="Arial"/>
-                <a:ea typeface="Arial"/>
-                <a:cs typeface="Arial"/>
-              </a:defRPr>
-            </a:pPr>
-            <a:r>
-              <a:rPr sz="1275" b="0">
-                <a:solidFill>
-                  <a:srgbClr val="596F75"/>
-                </a:solidFill>
-                <a:latin typeface="Arial"/>
-                <a:ea typeface="Arial"/>
-                <a:cs typeface="Arial"/>
-              </a:rPr>
-              <a:t>IS 507 Midterm  ·  8/11</a:t>
+            <a:r>
+              <a:t>IS 507 Midterm  ·  8/10</a:t>
             </a:r>
           </a:p>
         </p:txBody>
@@ -12526,26 +12327,8 @@
             </a:defPPr>
           </a:lstStyle>
           <a:p xmlns:a="http://schemas.openxmlformats.org/drawingml/2006/main">
-            <a:pPr>
-              <a:defRPr sz="1275" b="0">
-                <a:solidFill>
-                  <a:srgbClr val="596F75"/>
-                </a:solidFill>
-                <a:latin typeface="Arial"/>
-                <a:ea typeface="Arial"/>
-                <a:cs typeface="Arial"/>
-              </a:defRPr>
-            </a:pPr>
-            <a:r>
-              <a:rPr sz="1275" b="0">
-                <a:solidFill>
-                  <a:srgbClr val="596F75"/>
-                </a:solidFill>
-                <a:latin typeface="Arial"/>
-                <a:ea typeface="Arial"/>
-                <a:cs typeface="Arial"/>
-              </a:rPr>
-              <a:t>IS 507 Midterm  ·  9/11</a:t>
+            <a:r>
+              <a:t>IS 507 Midterm  ·  9/10</a:t>
             </a:r>
           </a:p>
         </p:txBody>

</xml_diff>

<commit_message>
Audit fixes: remove report section 9, visible DOIs, handbooks synced to 10 slides/7:45, RF line on conclusion slide
</commit_message>
<xml_diff>
--- a/deliverables/IS507_Midterm_Presentation.pptx
+++ b/deliverables/IS507_Midterm_Presentation.pptx
@@ -5862,26 +5862,8 @@
             </a:defPPr>
           </a:lstStyle>
           <a:p xmlns:a="http://schemas.openxmlformats.org/drawingml/2006/main">
-            <a:pPr>
-              <a:defRPr sz="2175" b="0">
-                <a:solidFill>
-                  <a:srgbClr val="BDD0CF"/>
-                </a:solidFill>
-                <a:latin typeface="Arial"/>
-                <a:ea typeface="Arial"/>
-                <a:cs typeface="Arial"/>
-              </a:defRPr>
-            </a:pPr>
-            <a:r>
-              <a:rPr sz="2175" b="0">
-                <a:solidFill>
-                  <a:srgbClr val="BDD0CF"/>
-                </a:solidFill>
-                <a:latin typeface="Arial"/>
-                <a:ea typeface="Arial"/>
-                <a:cs typeface="Arial"/>
-              </a:rPr>
-              <a:t>Next: original inputs, a justified cohort and a practical alert rule</a:t>
+            <a:r>
+              <a:t>Next: original inputs, a justified cohort and a practical alert rule; compare random forest with logistic regression</a:t>
             </a:r>
           </a:p>
         </p:txBody>

</xml_diff>